<commit_message>
Stop the pipeline on audit failures and reproduce from the committed snapshot by default
Live downloads now need --refresh. Adds a pinned lock file and a CI workflow, keys the forecast cache on source and config, keeps all 24 validation trials, executes the notebook and writes the deck to reports/.
</commit_message>
<xml_diff>
--- a/reports/presentation.pptx
+++ b/reports/presentation.pptx
@@ -2851,7 +2851,7 @@
       </p:sp>
       <p:pic>
         <p:nvPicPr>
-          <p:cNvPr id="6" name="Image 0" descr="/sessions/peaceful-trusting-darwin/mnt/Hackathon/figures/fig4_series_panel.png">    </p:cNvPr>
+          <p:cNvPr id="6" name="Image 0" descr="C:\Users\aakas\Documents\Projects\Hackathon\figures\input_series.png">    </p:cNvPr>
           <p:cNvPicPr>
             <a:picLocks noChangeAspect="1"/>
           </p:cNvPicPr>
@@ -2906,7 +2906,7 @@
                 <a:ea typeface="Arial" pitchFamily="34" charset="-122"/>
                 <a:cs typeface="Arial" pitchFamily="34" charset="-120"/>
               </a:rPr>
-              <a:t>SARB. MARKET_RATES 1.0.0. Pretoria: SARB [producer]. Johannesburg: EconData [distributor], 2026. Verification script: code/econdata_verify.py.</a:t>
+              <a:t>SARB. MARKET_RATES 1.0.0. Pretoria: SARB [producer]. Johannesburg: EconData [distributor], 2026. Verification script: src/verify_provenance.py.</a:t>
             </a:r>
             <a:endParaRPr lang="en-US" sz="1300" dirty="0"/>
           </a:p>
@@ -3049,7 +3049,7 @@
       </p:sp>
       <p:pic>
         <p:nvPicPr>
-          <p:cNvPr id="5" name="Image 0" descr="/sessions/peaceful-trusting-darwin/mnt/Hackathon/figures/fig5_weights.png">    </p:cNvPr>
+          <p:cNvPr id="5" name="Image 0" descr="C:\Users\aakas\Documents\Projects\Hackathon\figures\combination_weights.png">    </p:cNvPr>
           <p:cNvPicPr>
             <a:picLocks noChangeAspect="1"/>
           </p:cNvPicPr>
@@ -3793,7 +3793,7 @@
       </p:sp>
       <p:pic>
         <p:nvPicPr>
-          <p:cNvPr id="5" name="Image 0" descr="/sessions/peaceful-trusting-darwin/mnt/Hackathon/figures/fig3_forecasts.png">    </p:cNvPr>
+          <p:cNvPr id="5" name="Image 0" descr="C:\Users\aakas\Documents\Projects\Hackathon\figures\forecasts_vs_actual.png">    </p:cNvPr>
           <p:cNvPicPr>
             <a:picLocks noChangeAspect="1"/>
           </p:cNvPicPr>
@@ -6683,7 +6683,7 @@
       </p:sp>
       <p:pic>
         <p:nvPicPr>
-          <p:cNvPr id="4" name="Image 0" descr="/sessions/peaceful-trusting-darwin/mnt/Hackathon/figures/slides/slide_cumse.png">    </p:cNvPr>
+          <p:cNvPr id="4" name="Image 0" descr="C:\Users\aakas\Documents\Projects\Hackathon\figures\presentation\cumse.png">    </p:cNvPr>
           <p:cNvPicPr>
             <a:picLocks noChangeAspect="1"/>
           </p:cNvPicPr>
@@ -6943,7 +6943,7 @@
                 <a:ea typeface="Arial" pitchFamily="34" charset="-122"/>
                 <a:cs typeface="Arial" pitchFamily="34" charset="-120"/>
               </a:rPr>
-              <a:t>Own calculation. AR(1) refitted at each of the 261 origins; reproducible via code/verify_charts.py in the submission.</a:t>
+              <a:t>Own calculation. AR(1) refitted at each of the 261 origins; reproducible via src/validate_results.py in the submission.</a:t>
             </a:r>
             <a:endParaRPr lang="en-US" sz="1300" dirty="0"/>
           </a:p>
@@ -7047,7 +7047,7 @@
       </p:sp>
       <p:pic>
         <p:nvPicPr>
-          <p:cNvPr id="4" name="Image 0" descr="/sessions/peaceful-trusting-darwin/mnt/Hackathon/figures/slides/slide_rmse.png">    </p:cNvPr>
+          <p:cNvPr id="4" name="Image 0" descr="C:\Users\aakas\Documents\Projects\Hackathon\figures\presentation\rmse.png">    </p:cNvPr>
           <p:cNvPicPr>
             <a:picLocks noChangeAspect="1"/>
           </p:cNvPicPr>
@@ -11939,7 +11939,7 @@
       </p:sp>
       <p:pic>
         <p:nvPicPr>
-          <p:cNvPr id="5" name="Image 0" descr="/sessions/peaceful-trusting-darwin/mnt/Hackathon/figures/slides/slide_yearly.png">    </p:cNvPr>
+          <p:cNvPr id="5" name="Image 0" descr="C:\Users\aakas\Documents\Projects\Hackathon\figures\presentation\yearly.png">    </p:cNvPr>
           <p:cNvPicPr>
             <a:picLocks noChangeAspect="1"/>
           </p:cNvPicPr>

</xml_diff>

<commit_message>
Join predictors on when they were published, not when they were observed
Each series now carries an availability timestamp from its publisher's release schedule, and forecasts are issued Friday 17:00 Johannesburg time. Revised FRED series use ALFRED vintages. Adds a one-week extra-lag sensitivity run.
</commit_message>
<xml_diff>
--- a/reports/presentation.pptx
+++ b/reports/presentation.pptx
@@ -2347,7 +2347,7 @@
                 <a:ea typeface="Arial" pitchFamily="34" charset="-122"/>
                 <a:cs typeface="Arial" pitchFamily="34" charset="-120"/>
               </a:rPr>
-              <a:t>+0.42%</a:t>
+              <a:t>+0.43%</a:t>
             </a:r>
             <a:endParaRPr lang="en-US" sz="3400" dirty="0"/>
           </a:p>
@@ -3337,7 +3337,7 @@
                 <a:ea typeface="Arial" pitchFamily="34" charset="-122"/>
                 <a:cs typeface="Arial" pitchFamily="34" charset="-120"/>
               </a:rPr>
-              <a:t>We ran machine learning under identical rules and it lost by 7.5%</a:t>
+              <a:t>We ran machine learning under identical rules and it lost by 7.6%</a:t>
             </a:r>
             <a:endParaRPr lang="en-US" sz="2600" dirty="0"/>
           </a:p>
@@ -7185,7 +7185,7 @@
                 <a:ea typeface="Arial" pitchFamily="34" charset="-122"/>
                 <a:cs typeface="Arial" pitchFamily="34" charset="-120"/>
               </a:rPr>
-              <a:t>Gradient boosting, same data and discipline, loses by 7.5%. About 850 noisy observations cannot support a flexible learner.</a:t>
+              <a:t>Gradient boosting, same data and discipline, loses by 7.6%. About 850 noisy observations cannot support a flexible learner.</a:t>
             </a:r>
             <a:endParaRPr lang="en-US" sz="1800" dirty="0"/>
           </a:p>
@@ -7453,7 +7453,7 @@
                 <a:ea typeface="Arial" pitchFamily="34" charset="-122"/>
                 <a:cs typeface="Arial" pitchFamily="34" charset="-120"/>
               </a:rPr>
-              <a:t>Gradient boosting, run under identical rules, lost by 7.5%.</a:t>
+              <a:t>Gradient boosting, run under identical rules, lost by 7.6%.</a:t>
             </a:r>
             <a:endParaRPr lang="en-US" sz="1900" dirty="0"/>
           </a:p>
@@ -7490,7 +7490,7 @@
                 <a:ea typeface="Arial" pitchFamily="34" charset="-122"/>
                 <a:cs typeface="Arial" pitchFamily="34" charset="-120"/>
               </a:rPr>
-              <a:t>Not statistically significant (DM p = 0.47). The benchmark wins on MAE and in 2025. Untested as a trading strategy.</a:t>
+              <a:t>Not statistically significant (DM p = 0.46). The benchmark wins on MAE and in 2025. Untested as a trading strategy.</a:t>
             </a:r>
             <a:endParaRPr lang="en-US" sz="1900" dirty="0"/>
           </a:p>
@@ -10209,7 +10209,7 @@
                           <a:ea typeface="Arial" pitchFamily="34" charset="-122"/>
                           <a:cs typeface="Arial" pitchFamily="34" charset="-120"/>
                         </a:rPr>
-                        <a:t>+0.31%</a:t>
+                        <a:t>+0.32%</a:t>
                       </a:r>
                       <a:endParaRPr lang="en-US" sz="1300" dirty="0">
                         <a:latin typeface="Arial" charset="0"/>
@@ -10274,7 +10274,7 @@
                           <a:ea typeface="Arial" pitchFamily="34" charset="-122"/>
                           <a:cs typeface="Arial" pitchFamily="34" charset="-120"/>
                         </a:rPr>
-                        <a:t>0.768</a:t>
+                        <a:t>0.760</a:t>
                       </a:r>
                       <a:endParaRPr lang="en-US" sz="1300" dirty="0">
                         <a:latin typeface="Arial" charset="0"/>
@@ -10339,7 +10339,7 @@
                           <a:ea typeface="Arial" pitchFamily="34" charset="-122"/>
                           <a:cs typeface="Arial" pitchFamily="34" charset="-120"/>
                         </a:rPr>
-                        <a:t>0.5624</a:t>
+                        <a:t>0.5623</a:t>
                       </a:r>
                       <a:endParaRPr lang="en-US" sz="1300" dirty="0">
                         <a:latin typeface="Arial" charset="0"/>
@@ -10471,7 +10471,7 @@
                           <a:ea typeface="Arial" pitchFamily="34" charset="-122"/>
                           <a:cs typeface="Arial" pitchFamily="34" charset="-120"/>
                         </a:rPr>
-                        <a:t>0.5605</a:t>
+                        <a:t>0.5604</a:t>
                       </a:r>
                       <a:endParaRPr lang="en-US" sz="1300" dirty="0">
                         <a:latin typeface="Arial" charset="0"/>
@@ -10536,7 +10536,7 @@
                           <a:ea typeface="Arial" pitchFamily="34" charset="-122"/>
                           <a:cs typeface="Arial" pitchFamily="34" charset="-120"/>
                         </a:rPr>
-                        <a:t>0.4482</a:t>
+                        <a:t>0.4481</a:t>
                       </a:r>
                       <a:endParaRPr lang="en-US" sz="1300" dirty="0">
                         <a:latin typeface="Arial" charset="0"/>
@@ -10601,7 +10601,7 @@
                           <a:ea typeface="Arial" pitchFamily="34" charset="-122"/>
                           <a:cs typeface="Arial" pitchFamily="34" charset="-120"/>
                         </a:rPr>
-                        <a:t>46.4%</a:t>
+                        <a:t>51.0%</a:t>
                       </a:r>
                       <a:endParaRPr lang="en-US" sz="1300" dirty="0">
                         <a:latin typeface="Arial" charset="0"/>
@@ -10666,7 +10666,7 @@
                           <a:ea typeface="Arial" pitchFamily="34" charset="-122"/>
                           <a:cs typeface="Arial" pitchFamily="34" charset="-120"/>
                         </a:rPr>
-                        <a:t>+0.34%</a:t>
+                        <a:t>+0.35%</a:t>
                       </a:r>
                       <a:endParaRPr lang="en-US" sz="1300" dirty="0">
                         <a:latin typeface="Arial" charset="0"/>
@@ -10731,7 +10731,7 @@
                           <a:ea typeface="Arial" pitchFamily="34" charset="-122"/>
                           <a:cs typeface="Arial" pitchFamily="34" charset="-120"/>
                         </a:rPr>
-                        <a:t>0.334</a:t>
+                        <a:t>0.319</a:t>
                       </a:r>
                       <a:endParaRPr lang="en-US" sz="1300" dirty="0">
                         <a:latin typeface="Arial" charset="0"/>
@@ -10796,7 +10796,7 @@
                           <a:ea typeface="Arial" pitchFamily="34" charset="-122"/>
                           <a:cs typeface="Arial" pitchFamily="34" charset="-120"/>
                         </a:rPr>
-                        <a:t>0.5627</a:t>
+                        <a:t>0.5626</a:t>
                       </a:r>
                       <a:endParaRPr lang="en-US" sz="1300" dirty="0">
                         <a:latin typeface="Arial" charset="0"/>
@@ -10928,7 +10928,7 @@
                           <a:ea typeface="Arial" pitchFamily="34" charset="-122"/>
                           <a:cs typeface="Arial" pitchFamily="34" charset="-120"/>
                         </a:rPr>
-                        <a:t>0.6046</a:t>
+                        <a:t>0.6051</a:t>
                       </a:r>
                       <a:endParaRPr lang="en-US" sz="1300" dirty="0">
                         <a:latin typeface="Arial" charset="0"/>
@@ -10993,7 +10993,7 @@
                           <a:ea typeface="Arial" pitchFamily="34" charset="-122"/>
                           <a:cs typeface="Arial" pitchFamily="34" charset="-120"/>
                         </a:rPr>
-                        <a:t>0.4919</a:t>
+                        <a:t>0.4967</a:t>
                       </a:r>
                       <a:endParaRPr lang="en-US" sz="1300" dirty="0">
                         <a:latin typeface="Arial" charset="0"/>
@@ -11058,7 +11058,7 @@
                           <a:ea typeface="Arial" pitchFamily="34" charset="-122"/>
                           <a:cs typeface="Arial" pitchFamily="34" charset="-120"/>
                         </a:rPr>
-                        <a:t>49.4%</a:t>
+                        <a:t>46.4%</a:t>
                       </a:r>
                       <a:endParaRPr lang="en-US" sz="1300" dirty="0">
                         <a:latin typeface="Arial" charset="0"/>
@@ -11123,7 +11123,7 @@
                           <a:ea typeface="Arial" pitchFamily="34" charset="-122"/>
                           <a:cs typeface="Arial" pitchFamily="34" charset="-120"/>
                         </a:rPr>
-                        <a:t>-7.51%</a:t>
+                        <a:t>-7.60%</a:t>
                       </a:r>
                       <a:endParaRPr lang="en-US" sz="1300" dirty="0">
                         <a:latin typeface="Arial" charset="0"/>
@@ -11188,7 +11188,7 @@
                           <a:ea typeface="Arial" pitchFamily="34" charset="-122"/>
                           <a:cs typeface="Arial" pitchFamily="34" charset="-120"/>
                         </a:rPr>
-                        <a:t>0.042</a:t>
+                        <a:t>0.016</a:t>
                       </a:r>
                       <a:endParaRPr lang="en-US" sz="1300" dirty="0">
                         <a:latin typeface="Arial" charset="0"/>
@@ -11253,7 +11253,7 @@
                           <a:ea typeface="Arial" pitchFamily="34" charset="-122"/>
                           <a:cs typeface="Arial" pitchFamily="34" charset="-120"/>
                         </a:rPr>
-                        <a:t>0.6071</a:t>
+                        <a:t>0.6070</a:t>
                       </a:r>
                       <a:endParaRPr lang="en-US" sz="1300" dirty="0">
                         <a:latin typeface="Arial" charset="0"/>
@@ -11450,7 +11450,7 @@
                           <a:ea typeface="Arial" pitchFamily="34" charset="-122"/>
                           <a:cs typeface="Arial" pitchFamily="34" charset="-120"/>
                         </a:rPr>
-                        <a:t>0.4496</a:t>
+                        <a:t>0.4495</a:t>
                       </a:r>
                       <a:endParaRPr lang="en-US" sz="1300" dirty="0">
                         <a:latin typeface="Arial" charset="0"/>
@@ -11580,7 +11580,7 @@
                           <a:ea typeface="Arial" pitchFamily="34" charset="-122"/>
                           <a:cs typeface="Arial" pitchFamily="34" charset="-120"/>
                         </a:rPr>
-                        <a:t>+0.42%</a:t>
+                        <a:t>+0.43%</a:t>
                       </a:r>
                       <a:endParaRPr lang="en-US" sz="1300" dirty="0">
                         <a:latin typeface="Arial" charset="0"/>
@@ -11645,7 +11645,7 @@
                           <a:ea typeface="Arial" pitchFamily="34" charset="-122"/>
                           <a:cs typeface="Arial" pitchFamily="34" charset="-120"/>
                         </a:rPr>
-                        <a:t>0.469</a:t>
+                        <a:t>0.463</a:t>
                       </a:r>
                       <a:endParaRPr lang="en-US" sz="1300" dirty="0">
                         <a:latin typeface="Arial" charset="0"/>
@@ -11710,7 +11710,7 @@
                           <a:ea typeface="Arial" pitchFamily="34" charset="-122"/>
                           <a:cs typeface="Arial" pitchFamily="34" charset="-120"/>
                         </a:rPr>
-                        <a:t>0.5621</a:t>
+                        <a:t>0.5620</a:t>
                       </a:r>
                       <a:endParaRPr lang="en-US" sz="1300" dirty="0">
                         <a:latin typeface="Arial" charset="0"/>

</xml_diff>

<commit_message>
Purge overlapping targets from tuning folds and end validation before 2021 targets
Validation now stops at the 2020-11-27 origin. Ridge scaling is fitted inside each fold, gradient boosting gets a small tuning grid under the same purged protocol, and AR(1) in logs is fixed as the benchmark instead of being picked on the judged window.
</commit_message>
<xml_diff>
--- a/reports/presentation.pptx
+++ b/reports/presentation.pptx
@@ -2191,7 +2191,7 @@
                 <a:ea typeface="Arial" pitchFamily="34" charset="-122"/>
                 <a:cs typeface="Arial" pitchFamily="34" charset="-120"/>
               </a:rPr>
-              <a:t>0.5600</a:t>
+              <a:t>0.5599</a:t>
             </a:r>
             <a:endParaRPr lang="en-US" sz="3400" dirty="0"/>
           </a:p>
@@ -2347,7 +2347,7 @@
                 <a:ea typeface="Arial" pitchFamily="34" charset="-122"/>
                 <a:cs typeface="Arial" pitchFamily="34" charset="-120"/>
               </a:rPr>
-              <a:t>+0.43%</a:t>
+              <a:t>+0.44%</a:t>
             </a:r>
             <a:endParaRPr lang="en-US" sz="3400" dirty="0"/>
           </a:p>
@@ -3128,7 +3128,7 @@
                 <a:ea typeface="Arial" pitchFamily="34" charset="-122"/>
                 <a:cs typeface="Arial" pitchFamily="34" charset="-120"/>
               </a:rPr>
-              <a:t>ridge on the compact feature set, no intercept</a:t>
+              <a:t>ridge on the full feature set, no intercept</a:t>
             </a:r>
             <a:endParaRPr lang="en-US" sz="1700" dirty="0"/>
           </a:p>
@@ -3337,7 +3337,7 @@
                 <a:ea typeface="Arial" pitchFamily="34" charset="-122"/>
                 <a:cs typeface="Arial" pitchFamily="34" charset="-120"/>
               </a:rPr>
-              <a:t>We ran machine learning under identical rules and it lost by 7.6%</a:t>
+              <a:t>We ran machine learning under identical rules and it lost by 2.2%</a:t>
             </a:r>
             <a:endParaRPr lang="en-US" sz="2600" dirty="0"/>
           </a:p>
@@ -3506,7 +3506,7 @@
                 <a:ea typeface="Arial" pitchFamily="34" charset="-122"/>
                 <a:cs typeface="Arial" pitchFamily="34" charset="-120"/>
               </a:rPr>
-              <a:t>HistGradientBoosting, max depth 2, learning rate 0.05, 150 iterations, L2 regularisation 1.0, fixed seed. Identical information set, identical embargo, identical walk-forward loop as every other model.</a:t>
+              <a:t>HistGradientBoosting with a fixed seed. Once a year, purged cross-validation picks its depth, learning rate, iterations, L2 penalty and leaf size from 12 configurations. Same information set, same embargo and same walk-forward loop as every other model.</a:t>
             </a:r>
             <a:endParaRPr lang="en-US" sz="1800" dirty="0"/>
           </a:p>
@@ -7185,7 +7185,7 @@
                 <a:ea typeface="Arial" pitchFamily="34" charset="-122"/>
                 <a:cs typeface="Arial" pitchFamily="34" charset="-120"/>
               </a:rPr>
-              <a:t>Gradient boosting, same data and discipline, loses by 7.6%. About 850 noisy observations cannot support a flexible learner.</a:t>
+              <a:t>Gradient boosting, same data and discipline, loses by 2.2%. About 850 noisy observations cannot support a flexible learner.</a:t>
             </a:r>
             <a:endParaRPr lang="en-US" sz="1800" dirty="0"/>
           </a:p>
@@ -7453,7 +7453,7 @@
                 <a:ea typeface="Arial" pitchFamily="34" charset="-122"/>
                 <a:cs typeface="Arial" pitchFamily="34" charset="-120"/>
               </a:rPr>
-              <a:t>Gradient boosting, run under identical rules, lost by 7.6%.</a:t>
+              <a:t>Gradient boosting, run under identical rules, lost by 2.2%.</a:t>
             </a:r>
             <a:endParaRPr lang="en-US" sz="1900" dirty="0"/>
           </a:p>
@@ -7490,7 +7490,7 @@
                 <a:ea typeface="Arial" pitchFamily="34" charset="-122"/>
                 <a:cs typeface="Arial" pitchFamily="34" charset="-120"/>
               </a:rPr>
-              <a:t>Not statistically significant (DM p = 0.46). The benchmark wins on MAE and in 2025. Untested as a trading strategy.</a:t>
+              <a:t>Not statistically significant (DM p = 0.45). The benchmark wins on MAE and in 2025. Untested as a trading strategy.</a:t>
             </a:r>
             <a:endParaRPr lang="en-US" sz="1900" dirty="0"/>
           </a:p>
@@ -10471,7 +10471,7 @@
                           <a:ea typeface="Arial" pitchFamily="34" charset="-122"/>
                           <a:cs typeface="Arial" pitchFamily="34" charset="-120"/>
                         </a:rPr>
-                        <a:t>0.5604</a:t>
+                        <a:t>0.5602</a:t>
                       </a:r>
                       <a:endParaRPr lang="en-US" sz="1300" dirty="0">
                         <a:latin typeface="Arial" charset="0"/>
@@ -10536,7 +10536,7 @@
                           <a:ea typeface="Arial" pitchFamily="34" charset="-122"/>
                           <a:cs typeface="Arial" pitchFamily="34" charset="-120"/>
                         </a:rPr>
-                        <a:t>0.4481</a:t>
+                        <a:t>0.4479</a:t>
                       </a:r>
                       <a:endParaRPr lang="en-US" sz="1300" dirty="0">
                         <a:latin typeface="Arial" charset="0"/>
@@ -10601,7 +10601,7 @@
                           <a:ea typeface="Arial" pitchFamily="34" charset="-122"/>
                           <a:cs typeface="Arial" pitchFamily="34" charset="-120"/>
                         </a:rPr>
-                        <a:t>51.0%</a:t>
+                        <a:t>52.5%</a:t>
                       </a:r>
                       <a:endParaRPr lang="en-US" sz="1300" dirty="0">
                         <a:latin typeface="Arial" charset="0"/>
@@ -10666,7 +10666,7 @@
                           <a:ea typeface="Arial" pitchFamily="34" charset="-122"/>
                           <a:cs typeface="Arial" pitchFamily="34" charset="-120"/>
                         </a:rPr>
-                        <a:t>+0.35%</a:t>
+                        <a:t>+0.38%</a:t>
                       </a:r>
                       <a:endParaRPr lang="en-US" sz="1300" dirty="0">
                         <a:latin typeface="Arial" charset="0"/>
@@ -10731,7 +10731,7 @@
                           <a:ea typeface="Arial" pitchFamily="34" charset="-122"/>
                           <a:cs typeface="Arial" pitchFamily="34" charset="-120"/>
                         </a:rPr>
-                        <a:t>0.319</a:t>
+                        <a:t>0.264</a:t>
                       </a:r>
                       <a:endParaRPr lang="en-US" sz="1300" dirty="0">
                         <a:latin typeface="Arial" charset="0"/>
@@ -10796,7 +10796,7 @@
                           <a:ea typeface="Arial" pitchFamily="34" charset="-122"/>
                           <a:cs typeface="Arial" pitchFamily="34" charset="-120"/>
                         </a:rPr>
-                        <a:t>0.5626</a:t>
+                        <a:t>0.5623</a:t>
                       </a:r>
                       <a:endParaRPr lang="en-US" sz="1300" dirty="0">
                         <a:latin typeface="Arial" charset="0"/>
@@ -10928,7 +10928,7 @@
                           <a:ea typeface="Arial" pitchFamily="34" charset="-122"/>
                           <a:cs typeface="Arial" pitchFamily="34" charset="-120"/>
                         </a:rPr>
-                        <a:t>0.6051</a:t>
+                        <a:t>0.5745</a:t>
                       </a:r>
                       <a:endParaRPr lang="en-US" sz="1300" dirty="0">
                         <a:latin typeface="Arial" charset="0"/>
@@ -10993,7 +10993,7 @@
                           <a:ea typeface="Arial" pitchFamily="34" charset="-122"/>
                           <a:cs typeface="Arial" pitchFamily="34" charset="-120"/>
                         </a:rPr>
-                        <a:t>0.4967</a:t>
+                        <a:t>0.4723</a:t>
                       </a:r>
                       <a:endParaRPr lang="en-US" sz="1300" dirty="0">
                         <a:latin typeface="Arial" charset="0"/>
@@ -11058,7 +11058,7 @@
                           <a:ea typeface="Arial" pitchFamily="34" charset="-122"/>
                           <a:cs typeface="Arial" pitchFamily="34" charset="-120"/>
                         </a:rPr>
-                        <a:t>46.4%</a:t>
+                        <a:t>44.4%</a:t>
                       </a:r>
                       <a:endParaRPr lang="en-US" sz="1300" dirty="0">
                         <a:latin typeface="Arial" charset="0"/>
@@ -11123,7 +11123,7 @@
                           <a:ea typeface="Arial" pitchFamily="34" charset="-122"/>
                           <a:cs typeface="Arial" pitchFamily="34" charset="-120"/>
                         </a:rPr>
-                        <a:t>-7.60%</a:t>
+                        <a:t>-2.16%</a:t>
                       </a:r>
                       <a:endParaRPr lang="en-US" sz="1300" dirty="0">
                         <a:latin typeface="Arial" charset="0"/>
@@ -11188,7 +11188,7 @@
                           <a:ea typeface="Arial" pitchFamily="34" charset="-122"/>
                           <a:cs typeface="Arial" pitchFamily="34" charset="-120"/>
                         </a:rPr>
-                        <a:t>0.016</a:t>
+                        <a:t>0.362</a:t>
                       </a:r>
                       <a:endParaRPr lang="en-US" sz="1300" dirty="0">
                         <a:latin typeface="Arial" charset="0"/>
@@ -11253,7 +11253,7 @@
                           <a:ea typeface="Arial" pitchFamily="34" charset="-122"/>
                           <a:cs typeface="Arial" pitchFamily="34" charset="-120"/>
                         </a:rPr>
-                        <a:t>0.6070</a:t>
+                        <a:t>0.5755</a:t>
                       </a:r>
                       <a:endParaRPr lang="en-US" sz="1300" dirty="0">
                         <a:latin typeface="Arial" charset="0"/>
@@ -11385,7 +11385,7 @@
                           <a:ea typeface="Arial" pitchFamily="34" charset="-122"/>
                           <a:cs typeface="Arial" pitchFamily="34" charset="-120"/>
                         </a:rPr>
-                        <a:t>0.5600</a:t>
+                        <a:t>0.5599</a:t>
                       </a:r>
                       <a:endParaRPr lang="en-US" sz="1300" dirty="0">
                         <a:latin typeface="Arial" charset="0"/>
@@ -11580,7 +11580,7 @@
                           <a:ea typeface="Arial" pitchFamily="34" charset="-122"/>
                           <a:cs typeface="Arial" pitchFamily="34" charset="-120"/>
                         </a:rPr>
-                        <a:t>+0.43%</a:t>
+                        <a:t>+0.44%</a:t>
                       </a:r>
                       <a:endParaRPr lang="en-US" sz="1300" dirty="0">
                         <a:latin typeface="Arial" charset="0"/>
@@ -11645,7 +11645,7 @@
                           <a:ea typeface="Arial" pitchFamily="34" charset="-122"/>
                           <a:cs typeface="Arial" pitchFamily="34" charset="-120"/>
                         </a:rPr>
-                        <a:t>0.463</a:t>
+                        <a:t>0.449</a:t>
                       </a:r>
                       <a:endParaRPr lang="en-US" sz="1300" dirty="0">
                         <a:latin typeface="Arial" charset="0"/>
@@ -11710,7 +11710,7 @@
                           <a:ea typeface="Arial" pitchFamily="34" charset="-122"/>
                           <a:cs typeface="Arial" pitchFamily="34" charset="-120"/>
                         </a:rPr>
-                        <a:t>0.5620</a:t>
+                        <a:t>0.5619</a:t>
                       </a:r>
                       <a:endParaRPr lang="en-US" sz="1300" dirty="0">
                         <a:latin typeface="Arial" charset="0"/>

</xml_diff>

<commit_message>
Tighten the prose and remove dead code across the report, deck and scripts
</commit_message>
<xml_diff>
--- a/reports/presentation.pptx
+++ b/reports/presentation.pptx
@@ -2157,7 +2157,7 @@
                 <a:ea typeface="Arial" pitchFamily="34" charset="-122"/>
                 <a:cs typeface="Arial" pitchFamily="34" charset="-120"/>
               </a:rPr>
-              <a:t>Don't fight the random walk.</a:t>
+              <a:t>Forecasting the rand</a:t>
             </a:r>
             <a:endParaRPr lang="en-US" sz="4200" dirty="0"/>
           </a:p>
@@ -2177,7 +2177,7 @@
                 <a:ea typeface="Arial" pitchFamily="34" charset="-122"/>
                 <a:cs typeface="Arial" pitchFamily="34" charset="-120"/>
               </a:rPr>
-              <a:t>Discipline it.</a:t>
+              <a:t>one month ahead</a:t>
             </a:r>
             <a:endParaRPr lang="en-US" sz="4200" dirty="0"/>
           </a:p>
@@ -8080,7 +8080,7 @@
                 <a:ea typeface="Arial" pitchFamily="34" charset="-122"/>
                 <a:cs typeface="Arial" pitchFamily="34" charset="-120"/>
               </a:rPr>
-              <a:t>Nothing here is a black box. </a:t>
+              <a:t>Small enough to derive by hand. </a:t>
             </a:r>
             <a:pPr indent="0" marL="0">
               <a:buNone/>
@@ -8094,7 +8094,7 @@
                 <a:ea typeface="Arial" pitchFamily="34" charset="-122"/>
                 <a:cs typeface="Arial" pitchFamily="34" charset="-120"/>
               </a:rPr>
-              <a:t>OLS, ridge regression and a weighted average. We can derive every component by hand under questioning.</a:t>
+              <a:t>The combination is OLS, ridge regression and a weighted average, so every component can be worked through under questioning.</a:t>
             </a:r>
             <a:endParaRPr lang="en-US" sz="1800" dirty="0"/>
           </a:p>
@@ -8292,7 +8292,7 @@
                 <a:ea typeface="Arial" pitchFamily="34" charset="-122"/>
                 <a:cs typeface="Arial" pitchFamily="34" charset="-120"/>
               </a:rPr>
-              <a:t>What to take away</a:t>
+              <a:t>Reading the chart</a:t>
             </a:r>
             <a:endParaRPr lang="en-US" sz="2000" dirty="0"/>
           </a:p>
@@ -8656,7 +8656,7 @@
                 <a:ea typeface="Arial" pitchFamily="34" charset="-122"/>
                 <a:cs typeface="Arial" pitchFamily="34" charset="-120"/>
               </a:rPr>
-              <a:t>What to take away</a:t>
+              <a:t>The numbers</a:t>
             </a:r>
             <a:endParaRPr lang="en-US" sz="2000" dirty="0"/>
           </a:p>
@@ -9027,7 +9027,7 @@
                 <a:ea typeface="Arial" pitchFamily="34" charset="-122"/>
                 <a:cs typeface="Arial" pitchFamily="34" charset="-120"/>
               </a:rPr>
-              <a:t>Its implied level was below spot at 261 of 261 origins. That is an observation, not shown to be the full explanation.</a:t>
+              <a:t>Its implied level was below spot at 261 of 261 origins. We have not tested whether that is why it lost.</a:t>
             </a:r>
             <a:endParaRPr lang="en-US" sz="1900" dirty="0"/>
           </a:p>
@@ -9289,46 +9289,6 @@
         <p:txBody>
           <a:bodyPr wrap="square" lIns="0" tIns="0" rIns="0" bIns="0" rtlCol="0" anchor="ctr"/>
           <a:lstStyle/>
-          <a:p>
-            <a:pPr indent="0" marL="0">
-              <a:spcAft>
-                <a:spcPts val="900"/>
-              </a:spcAft>
-              <a:buNone/>
-            </a:pPr>
-            <a:r>
-              <a:rPr lang="en-US" sz="1400" dirty="0">
-                <a:solidFill>
-                  <a:srgbClr val="1F2937"/>
-                </a:solidFill>
-                <a:latin typeface="Arial" pitchFamily="34" charset="0"/>
-                <a:ea typeface="Arial" pitchFamily="34" charset="-122"/>
-                <a:cs typeface="Arial" pitchFamily="34" charset="-120"/>
-              </a:rPr>
-              <a:t>Amat, C., Michalski, T. and Stoltz, G. (2018). Fundamentals and exchange rate forecastability with simple machine learning methods. Journal of International Money and Finance, 88, 1-24.</a:t>
-            </a:r>
-            <a:endParaRPr lang="en-US" sz="1400" dirty="0"/>
-          </a:p>
-          <a:p>
-            <a:pPr indent="0" marL="0">
-              <a:spcAft>
-                <a:spcPts val="900"/>
-              </a:spcAft>
-              <a:buNone/>
-            </a:pPr>
-            <a:r>
-              <a:rPr lang="en-US" sz="1400" dirty="0">
-                <a:solidFill>
-                  <a:srgbClr val="1F2937"/>
-                </a:solidFill>
-                <a:latin typeface="Arial" pitchFamily="34" charset="0"/>
-                <a:ea typeface="Arial" pitchFamily="34" charset="-122"/>
-                <a:cs typeface="Arial" pitchFamily="34" charset="-120"/>
-              </a:rPr>
-              <a:t>Darvas, Z. (2020). Forecasting exchange rates of major currencies with long maturity interest rates. Bruegel Working Paper 2020/02.</a:t>
-            </a:r>
-            <a:endParaRPr lang="en-US" sz="1400" dirty="0"/>
-          </a:p>
           <a:p>
             <a:pPr indent="0" marL="0">
               <a:spcAft>

</xml_diff>

<commit_message>
Make the notebook, report and deck rebuild byte for byte from a clean clone
Pins statsmodels and its dependencies in the lock file, runs the notebook on the build interpreter with fixed cell ids, fixes PDF and PPTX timestamps, and normalises line endings.
</commit_message>
<xml_diff>
--- a/reports/presentation.pptx
+++ b/reports/presentation.pptx
@@ -2940,7 +2940,7 @@
       </p:sp>
       <p:pic>
         <p:nvPicPr>
-          <p:cNvPr id="6" name="Image 0" descr="C:\Users\aakas\Documents\Projects\Hackathon\figures\input_series.png">    </p:cNvPr>
+          <p:cNvPr id="6" name="Image 0" descr="C:\t\hk\figures\input_series.png">    </p:cNvPr>
           <p:cNvPicPr>
             <a:picLocks noChangeAspect="1"/>
           </p:cNvPicPr>
@@ -3138,7 +3138,7 @@
       </p:sp>
       <p:pic>
         <p:nvPicPr>
-          <p:cNvPr id="5" name="Image 0" descr="C:\Users\aakas\Documents\Projects\Hackathon\figures\combination_weights.png">    </p:cNvPr>
+          <p:cNvPr id="5" name="Image 0" descr="C:\t\hk\figures\combination_weights.png">    </p:cNvPr>
           <p:cNvPicPr>
             <a:picLocks noChangeAspect="1"/>
           </p:cNvPicPr>
@@ -3882,7 +3882,7 @@
       </p:sp>
       <p:pic>
         <p:nvPicPr>
-          <p:cNvPr id="5" name="Image 0" descr="C:\Users\aakas\Documents\Projects\Hackathon\figures\forecasts_vs_actual.png">    </p:cNvPr>
+          <p:cNvPr id="5" name="Image 0" descr="C:\t\hk\figures\forecasts_vs_actual.png">    </p:cNvPr>
           <p:cNvPicPr>
             <a:picLocks noChangeAspect="1"/>
           </p:cNvPicPr>
@@ -8237,7 +8237,7 @@
       </p:sp>
       <p:pic>
         <p:nvPicPr>
-          <p:cNvPr id="4" name="Image 0" descr="C:\Users\aakas\Documents\Projects\Hackathon\figures\presentation\cumse.png">    </p:cNvPr>
+          <p:cNvPr id="4" name="Image 0" descr="C:\t\hk\figures\presentation\cumse.png">    </p:cNvPr>
           <p:cNvPicPr>
             <a:picLocks noChangeAspect="1"/>
           </p:cNvPicPr>
@@ -8601,7 +8601,7 @@
       </p:sp>
       <p:pic>
         <p:nvPicPr>
-          <p:cNvPr id="4" name="Image 0" descr="C:\Users\aakas\Documents\Projects\Hackathon\figures\presentation\rmse.png">    </p:cNvPr>
+          <p:cNvPr id="4" name="Image 0" descr="C:\t\hk\figures\presentation\rmse.png">    </p:cNvPr>
           <p:cNvPicPr>
             <a:picLocks noChangeAspect="1"/>
           </p:cNvPicPr>
@@ -15270,7 +15270,7 @@
       </p:sp>
       <p:pic>
         <p:nvPicPr>
-          <p:cNvPr id="5" name="Image 0" descr="C:\Users\aakas\Documents\Projects\Hackathon\figures\presentation\yearly.png">    </p:cNvPr>
+          <p:cNvPr id="5" name="Image 0" descr="C:\t\hk\figures\presentation\yearly.png">    </p:cNvPr>
           <p:cNvPicPr>
             <a:picLocks noChangeAspect="1"/>
           </p:cNvPicPr>

</xml_diff>

<commit_message>
Give deck images alt text so the file no longer embeds local paths
</commit_message>
<xml_diff>
--- a/reports/presentation.pptx
+++ b/reports/presentation.pptx
@@ -2940,7 +2940,7 @@
       </p:sp>
       <p:pic>
         <p:nvPicPr>
-          <p:cNvPr id="6" name="Image 0" descr="C:\t\hk\figures\input_series.png">    </p:cNvPr>
+          <p:cNvPr id="6" name="Image 0" descr="Input series">    </p:cNvPr>
           <p:cNvPicPr>
             <a:picLocks noChangeAspect="1"/>
           </p:cNvPicPr>
@@ -3138,7 +3138,7 @@
       </p:sp>
       <p:pic>
         <p:nvPicPr>
-          <p:cNvPr id="5" name="Image 0" descr="C:\t\hk\figures\combination_weights.png">    </p:cNvPr>
+          <p:cNvPr id="5" name="Image 0" descr="Combination weights over time">    </p:cNvPr>
           <p:cNvPicPr>
             <a:picLocks noChangeAspect="1"/>
           </p:cNvPicPr>
@@ -3882,7 +3882,7 @@
       </p:sp>
       <p:pic>
         <p:nvPicPr>
-          <p:cNvPr id="5" name="Image 0" descr="C:\t\hk\figures\forecasts_vs_actual.png">    </p:cNvPr>
+          <p:cNvPr id="5" name="Image 0" descr="Forecasts against the realised rate">    </p:cNvPr>
           <p:cNvPicPr>
             <a:picLocks noChangeAspect="1"/>
           </p:cNvPicPr>
@@ -8237,7 +8237,7 @@
       </p:sp>
       <p:pic>
         <p:nvPicPr>
-          <p:cNvPr id="4" name="Image 0" descr="C:\t\hk\figures\presentation\cumse.png">    </p:cNvPr>
+          <p:cNvPr id="4" name="Image 0" descr="Cumulative squared-error gap against the AR(1)">    </p:cNvPr>
           <p:cNvPicPr>
             <a:picLocks noChangeAspect="1"/>
           </p:cNvPicPr>
@@ -8601,7 +8601,7 @@
       </p:sp>
       <p:pic>
         <p:nvPicPr>
-          <p:cNvPr id="4" name="Image 0" descr="C:\t\hk\figures\presentation\rmse.png">    </p:cNvPr>
+          <p:cNvPr id="4" name="Image 0" descr="RMSE by model">    </p:cNvPr>
           <p:cNvPicPr>
             <a:picLocks noChangeAspect="1"/>
           </p:cNvPicPr>
@@ -15270,7 +15270,7 @@
       </p:sp>
       <p:pic>
         <p:nvPicPr>
-          <p:cNvPr id="5" name="Image 0" descr="C:\t\hk\figures\presentation\yearly.png">    </p:cNvPr>
+          <p:cNvPr id="5" name="Image 0" descr="RMSE by year">    </p:cNvPr>
           <p:cNvPicPr>
             <a:picLocks noChangeAspect="1"/>
           </p:cNvPicPr>

</xml_diff>